<commit_message>
fix(auth): move auth gate from middleware to client (iOS PWA cookie race) + wait for session before redirect after login
</commit_message>
<xml_diff>
--- a/KariDesk-Magaziny.pptx
+++ b/KariDesk-Magaziny.pptx
@@ -15,9 +15,10 @@
     <p:sldId id="263" r:id="rId9"/>
     <p:sldId id="264" r:id="rId10"/>
     <p:sldId id="265" r:id="rId11"/>
+    <p:sldId id="266" r:id="rId12"/>
   </p:sldIdLst>
   <p:notesMasterIdLst>
-    <p:notesMasterId r:id="rId12"/>
+    <p:notesMasterId r:id="rId13"/>
   </p:notesMasterIdLst>
   <p:sldSz cx="9144000" cy="5143500"/>
   <p:notesSz cx="5143500" cy="9144000"/>
@@ -641,6 +642,94 @@
 </p:notes>
 </file>
 
+<file path=ppt/notesSlides/notesSlide11.xml><?xml version="1.0" encoding="utf-8"?>
+<p:notes xmlns:a="http://schemas.openxmlformats.org/drawingml/2006/main" xmlns:r="http://schemas.openxmlformats.org/officeDocument/2006/relationships" xmlns:p="http://schemas.openxmlformats.org/presentationml/2006/main">
+  <p:cSld>
+    <p:spTree>
+      <p:nvGrpSpPr>
+        <p:cNvPr id="1" name=""/>
+        <p:cNvGrpSpPr/>
+        <p:nvPr/>
+      </p:nvGrpSpPr>
+      <p:grpSpPr>
+        <a:xfrm>
+          <a:off x="0" y="0"/>
+          <a:ext cx="0" cy="0"/>
+          <a:chOff x="0" y="0"/>
+          <a:chExt cx="0" cy="0"/>
+        </a:xfrm>
+      </p:grpSpPr>
+      <p:sp>
+        <p:nvSpPr>
+          <p:cNvPr id="2" name="Slide Image Placeholder 1"/>
+          <p:cNvSpPr>
+            <a:spLocks noGrp="1" noRot="1" noChangeAspect="1"/>
+          </p:cNvSpPr>
+          <p:nvPr>
+            <p:ph type="sldImg"/>
+          </p:nvPr>
+        </p:nvSpPr>
+        <p:spPr/>
+      </p:sp>
+      <p:sp>
+        <p:nvSpPr>
+          <p:cNvPr id="3" name="Notes Placeholder 2"/>
+          <p:cNvSpPr>
+            <a:spLocks noGrp="1"/>
+          </p:cNvSpPr>
+          <p:nvPr>
+            <p:ph type="body" idx="1"/>
+          </p:nvPr>
+        </p:nvSpPr>
+        <p:spPr/>
+        <p:txBody>
+          <a:bodyPr/>
+          <a:lstStyle/>
+          <a:p>
+            <a:r>
+              <a:rPr lang="en-US" dirty="0"/>
+              <a:t/>
+            </a:r>
+            <a:endParaRPr lang="en-US" dirty="0"/>
+          </a:p>
+        </p:txBody>
+      </p:sp>
+      <p:sp>
+        <p:nvSpPr>
+          <p:cNvPr id="4" name="Slide Number Placeholder 3"/>
+          <p:cNvSpPr>
+            <a:spLocks noGrp="1"/>
+          </p:cNvSpPr>
+          <p:nvPr>
+            <p:ph type="sldNum" sz="quarter" idx="10"/>
+          </p:nvPr>
+        </p:nvSpPr>
+        <p:spPr/>
+        <p:txBody>
+          <a:bodyPr/>
+          <a:lstStyle/>
+          <a:p>
+            <a:fld id="{F7021451-1387-4CA6-816F-3879F97B5CBC}" type="slidenum">
+              <a:rPr lang="en-US"/>
+              <a:t>11</a:t>
+            </a:fld>
+            <a:endParaRPr lang="en-US"/>
+          </a:p>
+        </p:txBody>
+      </p:sp>
+    </p:spTree>
+    <p:extLst>
+      <p:ext uri="{BB962C8B-B14F-4D97-AF65-F5344CB8AC3E}">
+        <p14:creationId xmlns:p14="http://schemas.microsoft.com/office/powerpoint/2010/main" val="1024086991"/>
+      </p:ext>
+    </p:extLst>
+  </p:cSld>
+  <p:clrMapOvr>
+    <a:masterClrMapping/>
+  </p:clrMapOvr>
+</p:notes>
+</file>
+
 <file path=ppt/notesSlides/notesSlide2.xml><?xml version="1.0" encoding="utf-8"?>
 <p:notes xmlns:a="http://schemas.openxmlformats.org/drawingml/2006/main" xmlns:r="http://schemas.openxmlformats.org/officeDocument/2006/relationships" xmlns:p="http://schemas.openxmlformats.org/presentationml/2006/main">
   <p:cSld>
@@ -1937,6 +2026,572 @@
         </p:nvSpPr>
         <p:spPr>
           <a:xfrm>
+            <a:off x="0" y="0"/>
+            <a:ext cx="45720" cy="5143500"/>
+          </a:xfrm>
+          <a:prstGeom prst="rect">
+            <a:avLst/>
+          </a:prstGeom>
+          <a:solidFill>
+            <a:srgbClr val="E91E8C"/>
+          </a:solidFill>
+          <a:ln/>
+        </p:spPr>
+      </p:sp>
+      <p:sp>
+        <p:nvSpPr>
+          <p:cNvPr id="3" name="Shape 1"/>
+          <p:cNvSpPr/>
+          <p:nvPr/>
+        </p:nvSpPr>
+        <p:spPr>
+          <a:xfrm>
+            <a:off x="45720" y="0"/>
+            <a:ext cx="45720" cy="5143500"/>
+          </a:xfrm>
+          <a:prstGeom prst="rect">
+            <a:avLst/>
+          </a:prstGeom>
+          <a:solidFill>
+            <a:srgbClr val="A855F7"/>
+          </a:solidFill>
+          <a:ln/>
+        </p:spPr>
+      </p:sp>
+      <p:sp>
+        <p:nvSpPr>
+          <p:cNvPr id="4" name="Text 2"/>
+          <p:cNvSpPr/>
+          <p:nvPr/>
+        </p:nvSpPr>
+        <p:spPr>
+          <a:xfrm>
+            <a:off x="7589520" y="182880"/>
+            <a:ext cx="1371600" cy="274320"/>
+          </a:xfrm>
+          <a:prstGeom prst="rect">
+            <a:avLst/>
+          </a:prstGeom>
+          <a:noFill/>
+          <a:ln/>
+        </p:spPr>
+        <p:txBody>
+          <a:bodyPr wrap="square" lIns="0" tIns="0" rIns="0" bIns="0" rtlCol="0" anchor="ctr"/>
+          <a:lstStyle/>
+          <a:p>
+            <a:pPr algn="r" indent="0" marL="0">
+              <a:buNone/>
+            </a:pPr>
+            <a:r>
+              <a:rPr lang="en-US" sz="1100" dirty="0">
+                <a:solidFill>
+                  <a:srgbClr val="7C7C9C"/>
+                </a:solidFill>
+                <a:latin typeface="Helvetica" pitchFamily="34" charset="0"/>
+                <a:ea typeface="Helvetica" pitchFamily="34" charset="-122"/>
+                <a:cs typeface="Helvetica" pitchFamily="34" charset="-120"/>
+              </a:rPr>
+              <a:t>KariDesk</a:t>
+            </a:r>
+            <a:endParaRPr lang="en-US" sz="1100" dirty="0"/>
+          </a:p>
+        </p:txBody>
+      </p:sp>
+      <p:sp>
+        <p:nvSpPr>
+          <p:cNvPr id="5" name="Text 3"/>
+          <p:cNvSpPr/>
+          <p:nvPr/>
+        </p:nvSpPr>
+        <p:spPr>
+          <a:xfrm>
+            <a:off x="548640" y="411480"/>
+            <a:ext cx="7315200" cy="274320"/>
+          </a:xfrm>
+          <a:prstGeom prst="rect">
+            <a:avLst/>
+          </a:prstGeom>
+          <a:noFill/>
+          <a:ln/>
+        </p:spPr>
+        <p:txBody>
+          <a:bodyPr wrap="square" lIns="0" tIns="0" rIns="0" bIns="0" rtlCol="0" anchor="ctr"/>
+          <a:lstStyle/>
+          <a:p>
+            <a:pPr indent="0" marL="0">
+              <a:buNone/>
+            </a:pPr>
+            <a:r>
+              <a:rPr lang="en-US" sz="1100" b="1" spc="400" kern="0" dirty="0">
+                <a:solidFill>
+                  <a:srgbClr val="E91E8C"/>
+                </a:solidFill>
+                <a:latin typeface="Helvetica" pitchFamily="34" charset="0"/>
+                <a:ea typeface="Helvetica" pitchFamily="34" charset="-122"/>
+                <a:cs typeface="Helvetica" pitchFamily="34" charset="-120"/>
+              </a:rPr>
+              <a:t>09 — ЕСЛИ ЧТО-ТО ЗАВИСЛО</a:t>
+            </a:r>
+            <a:endParaRPr lang="en-US" sz="1100" dirty="0"/>
+          </a:p>
+        </p:txBody>
+      </p:sp>
+      <p:sp>
+        <p:nvSpPr>
+          <p:cNvPr id="6" name="Text 4"/>
+          <p:cNvSpPr/>
+          <p:nvPr/>
+        </p:nvSpPr>
+        <p:spPr>
+          <a:xfrm>
+            <a:off x="548640" y="731520"/>
+            <a:ext cx="8229600" cy="914400"/>
+          </a:xfrm>
+          <a:prstGeom prst="rect">
+            <a:avLst/>
+          </a:prstGeom>
+          <a:noFill/>
+          <a:ln/>
+        </p:spPr>
+        <p:txBody>
+          <a:bodyPr wrap="square" lIns="0" tIns="0" rIns="0" bIns="0" rtlCol="0" anchor="ctr"/>
+          <a:lstStyle/>
+          <a:p>
+            <a:pPr indent="0" marL="0">
+              <a:buNone/>
+            </a:pPr>
+            <a:r>
+              <a:rPr lang="en-US" sz="4000" b="1" dirty="0">
+                <a:solidFill>
+                  <a:srgbClr val="FFFFFF"/>
+                </a:solidFill>
+                <a:latin typeface="Helvetica" pitchFamily="34" charset="0"/>
+                <a:ea typeface="Helvetica" pitchFamily="34" charset="-122"/>
+                <a:cs typeface="Helvetica" pitchFamily="34" charset="-120"/>
+              </a:rPr>
+              <a:t>Обновления и сброс</a:t>
+            </a:r>
+            <a:endParaRPr lang="en-US" sz="4000" dirty="0"/>
+          </a:p>
+        </p:txBody>
+      </p:sp>
+      <p:sp>
+        <p:nvSpPr>
+          <p:cNvPr id="7" name="Shape 5"/>
+          <p:cNvSpPr/>
+          <p:nvPr/>
+        </p:nvSpPr>
+        <p:spPr>
+          <a:xfrm>
+            <a:off x="365760" y="1828800"/>
+            <a:ext cx="4023360" cy="2377440"/>
+          </a:xfrm>
+          <a:prstGeom prst="rect">
+            <a:avLst/>
+          </a:prstGeom>
+          <a:solidFill>
+            <a:srgbClr val="1A1A2E"/>
+          </a:solidFill>
+          <a:ln w="12700">
+            <a:solidFill>
+              <a:srgbClr val="2A2A4A"/>
+            </a:solidFill>
+            <a:prstDash val="solid"/>
+          </a:ln>
+          <a:effectLst>
+            <a:outerShdw sx="100000" sy="100000" kx="0" ky="0" algn="bl" rotWithShape="0" blurRad="152400" dist="50800" dir="5400000">
+              <a:srgbClr val="000000">
+                <a:alpha val="35000"/>
+              </a:srgbClr>
+            </a:outerShdw>
+          </a:effectLst>
+        </p:spPr>
+      </p:sp>
+      <p:sp>
+        <p:nvSpPr>
+          <p:cNvPr id="8" name="Shape 6"/>
+          <p:cNvSpPr/>
+          <p:nvPr/>
+        </p:nvSpPr>
+        <p:spPr>
+          <a:xfrm>
+            <a:off x="365760" y="1828800"/>
+            <a:ext cx="54864" cy="2377440"/>
+          </a:xfrm>
+          <a:prstGeom prst="rect">
+            <a:avLst/>
+          </a:prstGeom>
+          <a:solidFill>
+            <a:srgbClr val="34D399"/>
+          </a:solidFill>
+          <a:ln/>
+        </p:spPr>
+      </p:sp>
+      <p:sp>
+        <p:nvSpPr>
+          <p:cNvPr id="9" name="Text 7"/>
+          <p:cNvSpPr/>
+          <p:nvPr/>
+        </p:nvSpPr>
+        <p:spPr>
+          <a:xfrm>
+            <a:off x="640080" y="2103120"/>
+            <a:ext cx="3474720" cy="457200"/>
+          </a:xfrm>
+          <a:prstGeom prst="rect">
+            <a:avLst/>
+          </a:prstGeom>
+          <a:noFill/>
+          <a:ln/>
+        </p:spPr>
+        <p:txBody>
+          <a:bodyPr wrap="square" lIns="0" tIns="0" rIns="0" bIns="0" rtlCol="0" anchor="ctr"/>
+          <a:lstStyle/>
+          <a:p>
+            <a:pPr indent="0" marL="0">
+              <a:buNone/>
+            </a:pPr>
+            <a:r>
+              <a:rPr lang="en-US" sz="1800" b="1" dirty="0">
+                <a:solidFill>
+                  <a:srgbClr val="FFFFFF"/>
+                </a:solidFill>
+                <a:latin typeface="Helvetica" pitchFamily="34" charset="0"/>
+                <a:ea typeface="Helvetica" pitchFamily="34" charset="-122"/>
+                <a:cs typeface="Helvetica" pitchFamily="34" charset="-120"/>
+              </a:rPr>
+              <a:t>Обновления — сами</a:t>
+            </a:r>
+            <a:endParaRPr lang="en-US" sz="1800" dirty="0"/>
+          </a:p>
+        </p:txBody>
+      </p:sp>
+      <p:sp>
+        <p:nvSpPr>
+          <p:cNvPr id="10" name="Text 8"/>
+          <p:cNvSpPr/>
+          <p:nvPr/>
+        </p:nvSpPr>
+        <p:spPr>
+          <a:xfrm>
+            <a:off x="640080" y="2606040"/>
+            <a:ext cx="3474720" cy="1463040"/>
+          </a:xfrm>
+          <a:prstGeom prst="rect">
+            <a:avLst/>
+          </a:prstGeom>
+          <a:noFill/>
+          <a:ln/>
+        </p:spPr>
+        <p:txBody>
+          <a:bodyPr wrap="square" lIns="0" tIns="0" rIns="0" bIns="0" rtlCol="0" anchor="ctr"/>
+          <a:lstStyle/>
+          <a:p>
+            <a:pPr indent="0" marL="0">
+              <a:buNone/>
+            </a:pPr>
+            <a:r>
+              <a:rPr lang="en-US" sz="1300" dirty="0">
+                <a:solidFill>
+                  <a:srgbClr val="C4C4D8"/>
+                </a:solidFill>
+                <a:latin typeface="Helvetica" pitchFamily="34" charset="0"/>
+                <a:ea typeface="Helvetica" pitchFamily="34" charset="-122"/>
+                <a:cs typeface="Helvetica" pitchFamily="34" charset="-120"/>
+              </a:rPr>
+              <a:t>Когда мы выпускаем обновление — приложение само подхватит его при следующем открытии. Удалять иконку и ставить заново НЕ нужно.</a:t>
+            </a:r>
+            <a:endParaRPr lang="en-US" sz="1300" dirty="0"/>
+          </a:p>
+        </p:txBody>
+      </p:sp>
+      <p:sp>
+        <p:nvSpPr>
+          <p:cNvPr id="11" name="Shape 9"/>
+          <p:cNvSpPr/>
+          <p:nvPr/>
+        </p:nvSpPr>
+        <p:spPr>
+          <a:xfrm>
+            <a:off x="4754880" y="1828800"/>
+            <a:ext cx="4023360" cy="2377440"/>
+          </a:xfrm>
+          <a:prstGeom prst="rect">
+            <a:avLst/>
+          </a:prstGeom>
+          <a:solidFill>
+            <a:srgbClr val="1A1A2E"/>
+          </a:solidFill>
+          <a:ln w="12700">
+            <a:solidFill>
+              <a:srgbClr val="2A2A4A"/>
+            </a:solidFill>
+            <a:prstDash val="solid"/>
+          </a:ln>
+          <a:effectLst>
+            <a:outerShdw sx="100000" sy="100000" kx="0" ky="0" algn="bl" rotWithShape="0" blurRad="152400" dist="50800" dir="5400000">
+              <a:srgbClr val="000000">
+                <a:alpha val="35000"/>
+              </a:srgbClr>
+            </a:outerShdw>
+          </a:effectLst>
+        </p:spPr>
+      </p:sp>
+      <p:sp>
+        <p:nvSpPr>
+          <p:cNvPr id="12" name="Shape 10"/>
+          <p:cNvSpPr/>
+          <p:nvPr/>
+        </p:nvSpPr>
+        <p:spPr>
+          <a:xfrm>
+            <a:off x="4754880" y="1828800"/>
+            <a:ext cx="54864" cy="2377440"/>
+          </a:xfrm>
+          <a:prstGeom prst="rect">
+            <a:avLst/>
+          </a:prstGeom>
+          <a:solidFill>
+            <a:srgbClr val="E91E8C"/>
+          </a:solidFill>
+          <a:ln/>
+        </p:spPr>
+      </p:sp>
+      <p:sp>
+        <p:nvSpPr>
+          <p:cNvPr id="13" name="Text 11"/>
+          <p:cNvSpPr/>
+          <p:nvPr/>
+        </p:nvSpPr>
+        <p:spPr>
+          <a:xfrm>
+            <a:off x="5029200" y="2103120"/>
+            <a:ext cx="3474720" cy="457200"/>
+          </a:xfrm>
+          <a:prstGeom prst="rect">
+            <a:avLst/>
+          </a:prstGeom>
+          <a:noFill/>
+          <a:ln/>
+        </p:spPr>
+        <p:txBody>
+          <a:bodyPr wrap="square" lIns="0" tIns="0" rIns="0" bIns="0" rtlCol="0" anchor="ctr"/>
+          <a:lstStyle/>
+          <a:p>
+            <a:pPr indent="0" marL="0">
+              <a:buNone/>
+            </a:pPr>
+            <a:r>
+              <a:rPr lang="en-US" sz="1800" b="1" dirty="0">
+                <a:solidFill>
+                  <a:srgbClr val="FFFFFF"/>
+                </a:solidFill>
+                <a:latin typeface="Helvetica" pitchFamily="34" charset="0"/>
+                <a:ea typeface="Helvetica" pitchFamily="34" charset="-122"/>
+                <a:cs typeface="Helvetica" pitchFamily="34" charset="-120"/>
+              </a:rPr>
+              <a:t>Если зависло</a:t>
+            </a:r>
+            <a:endParaRPr lang="en-US" sz="1800" dirty="0"/>
+          </a:p>
+        </p:txBody>
+      </p:sp>
+      <p:sp>
+        <p:nvSpPr>
+          <p:cNvPr id="14" name="Text 12"/>
+          <p:cNvSpPr/>
+          <p:nvPr/>
+        </p:nvSpPr>
+        <p:spPr>
+          <a:xfrm>
+            <a:off x="5029200" y="2606040"/>
+            <a:ext cx="3474720" cy="1097280"/>
+          </a:xfrm>
+          <a:prstGeom prst="rect">
+            <a:avLst/>
+          </a:prstGeom>
+          <a:noFill/>
+          <a:ln/>
+        </p:spPr>
+        <p:txBody>
+          <a:bodyPr wrap="square" lIns="0" tIns="0" rIns="0" bIns="0" rtlCol="0" anchor="ctr"/>
+          <a:lstStyle/>
+          <a:p>
+            <a:pPr indent="0" marL="0">
+              <a:buNone/>
+            </a:pPr>
+            <a:r>
+              <a:rPr lang="en-US" sz="1300" dirty="0">
+                <a:solidFill>
+                  <a:srgbClr val="C4C4D8"/>
+                </a:solidFill>
+                <a:latin typeface="Helvetica" pitchFamily="34" charset="0"/>
+                <a:ea typeface="Helvetica" pitchFamily="34" charset="-122"/>
+                <a:cs typeface="Helvetica" pitchFamily="34" charset="-120"/>
+              </a:rPr>
+              <a:t>Откройте «Настройки» в приложении → нажмите «Обновить кеш и перезайти». Аккаунт и данные не теряются.</a:t>
+            </a:r>
+            <a:endParaRPr lang="en-US" sz="1300" dirty="0"/>
+          </a:p>
+        </p:txBody>
+      </p:sp>
+      <p:sp>
+        <p:nvSpPr>
+          <p:cNvPr id="15" name="Text 13"/>
+          <p:cNvSpPr/>
+          <p:nvPr/>
+        </p:nvSpPr>
+        <p:spPr>
+          <a:xfrm>
+            <a:off x="5029200" y="3520440"/>
+            <a:ext cx="3474720" cy="274320"/>
+          </a:xfrm>
+          <a:prstGeom prst="rect">
+            <a:avLst/>
+          </a:prstGeom>
+          <a:noFill/>
+          <a:ln/>
+        </p:spPr>
+        <p:txBody>
+          <a:bodyPr wrap="square" lIns="0" tIns="0" rIns="0" bIns="0" rtlCol="0" anchor="ctr"/>
+          <a:lstStyle/>
+          <a:p>
+            <a:pPr indent="0" marL="0">
+              <a:buNone/>
+            </a:pPr>
+            <a:r>
+              <a:rPr lang="en-US" sz="1100" dirty="0">
+                <a:solidFill>
+                  <a:srgbClr val="7C7C9C"/>
+                </a:solidFill>
+                <a:latin typeface="Helvetica" pitchFamily="34" charset="0"/>
+                <a:ea typeface="Helvetica" pitchFamily="34" charset="-122"/>
+                <a:cs typeface="Helvetica" pitchFamily="34" charset="-120"/>
+              </a:rPr>
+              <a:t>Резервный вариант:</a:t>
+            </a:r>
+            <a:endParaRPr lang="en-US" sz="1100" dirty="0"/>
+          </a:p>
+        </p:txBody>
+      </p:sp>
+      <p:sp>
+        <p:nvSpPr>
+          <p:cNvPr id="16" name="Text 14"/>
+          <p:cNvSpPr/>
+          <p:nvPr/>
+        </p:nvSpPr>
+        <p:spPr>
+          <a:xfrm>
+            <a:off x="5029200" y="3749040"/>
+            <a:ext cx="3474720" cy="365760"/>
+          </a:xfrm>
+          <a:prstGeom prst="rect">
+            <a:avLst/>
+          </a:prstGeom>
+          <a:noFill/>
+          <a:ln/>
+        </p:spPr>
+        <p:txBody>
+          <a:bodyPr wrap="square" lIns="0" tIns="0" rIns="0" bIns="0" rtlCol="0" anchor="ctr"/>
+          <a:lstStyle/>
+          <a:p>
+            <a:pPr indent="0" marL="0">
+              <a:buNone/>
+            </a:pPr>
+            <a:r>
+              <a:rPr lang="en-US" sz="1400" b="1" dirty="0">
+                <a:solidFill>
+                  <a:srgbClr val="E91E8C"/>
+                </a:solidFill>
+                <a:latin typeface="Helvetica" pitchFamily="34" charset="0"/>
+                <a:ea typeface="Helvetica" pitchFamily="34" charset="-122"/>
+                <a:cs typeface="Helvetica" pitchFamily="34" charset="-120"/>
+              </a:rPr>
+              <a:t>24karidesk.ru/reset</a:t>
+            </a:r>
+            <a:endParaRPr lang="en-US" sz="1400" dirty="0"/>
+          </a:p>
+        </p:txBody>
+      </p:sp>
+      <p:sp>
+        <p:nvSpPr>
+          <p:cNvPr id="17" name="Text 15"/>
+          <p:cNvSpPr/>
+          <p:nvPr/>
+        </p:nvSpPr>
+        <p:spPr>
+          <a:xfrm>
+            <a:off x="8046720" y="4732020"/>
+            <a:ext cx="914400" cy="274320"/>
+          </a:xfrm>
+          <a:prstGeom prst="rect">
+            <a:avLst/>
+          </a:prstGeom>
+          <a:noFill/>
+          <a:ln/>
+        </p:spPr>
+        <p:txBody>
+          <a:bodyPr wrap="square" lIns="0" tIns="0" rIns="0" bIns="0" rtlCol="0" anchor="ctr"/>
+          <a:lstStyle/>
+          <a:p>
+            <a:pPr algn="r" indent="0" marL="0">
+              <a:buNone/>
+            </a:pPr>
+            <a:r>
+              <a:rPr lang="en-US" sz="1000" dirty="0">
+                <a:solidFill>
+                  <a:srgbClr val="7C7C9C"/>
+                </a:solidFill>
+                <a:latin typeface="Helvetica" pitchFamily="34" charset="0"/>
+                <a:ea typeface="Helvetica" pitchFamily="34" charset="-122"/>
+                <a:cs typeface="Helvetica" pitchFamily="34" charset="-120"/>
+              </a:rPr>
+              <a:t>10 / 11</a:t>
+            </a:r>
+            <a:endParaRPr lang="en-US" sz="1000" dirty="0"/>
+          </a:p>
+        </p:txBody>
+      </p:sp>
+    </p:spTree>
+  </p:cSld>
+  <p:clrMapOvr>
+    <a:masterClrMapping/>
+  </p:clrMapOvr>
+</p:sld>
+</file>
+
+<file path=ppt/slides/slide11.xml><?xml version="1.0" encoding="utf-8"?>
+<p:sld xmlns:a="http://schemas.openxmlformats.org/drawingml/2006/main" xmlns:r="http://schemas.openxmlformats.org/officeDocument/2006/relationships" xmlns:p="http://schemas.openxmlformats.org/presentationml/2006/main">
+  <p:cSld name="Slide 11">
+    <p:bg>
+      <p:bgPr>
+        <a:solidFill>
+          <a:srgbClr val="08080C"/>
+        </a:solidFill>
+      </p:bgPr>
+    </p:bg>
+    <p:spTree>
+      <p:nvGrpSpPr>
+        <p:cNvPr id="1" name=""/>
+        <p:cNvGrpSpPr/>
+        <p:nvPr/>
+      </p:nvGrpSpPr>
+      <p:grpSpPr>
+        <a:xfrm>
+          <a:off x="0" y="0"/>
+          <a:ext cx="0" cy="0"/>
+          <a:chOff x="0" y="0"/>
+          <a:chExt cx="0" cy="0"/>
+        </a:xfrm>
+      </p:grpSpPr>
+      <p:sp>
+        <p:nvSpPr>
+          <p:cNvPr id="2" name="Shape 0"/>
+          <p:cNvSpPr/>
+          <p:nvPr/>
+        </p:nvSpPr>
+        <p:spPr>
+          <a:xfrm>
             <a:off x="-1371600" y="2286000"/>
             <a:ext cx="4572000" cy="4572000"/>
           </a:xfrm>
@@ -2832,7 +3487,7 @@
                 <a:ea typeface="Helvetica" pitchFamily="34" charset="-122"/>
                 <a:cs typeface="Helvetica" pitchFamily="34" charset="-120"/>
               </a:rPr>
-              <a:t>02 / 10</a:t>
+              <a:t>02 / 11</a:t>
             </a:r>
             <a:endParaRPr lang="en-US" sz="1000" dirty="0"/>
           </a:p>
@@ -3430,7 +4085,7 @@
                 <a:ea typeface="Helvetica" pitchFamily="34" charset="-122"/>
                 <a:cs typeface="Helvetica" pitchFamily="34" charset="-120"/>
               </a:rPr>
-              <a:t>03 / 10</a:t>
+              <a:t>03 / 11</a:t>
             </a:r>
             <a:endParaRPr lang="en-US" sz="1000" dirty="0"/>
           </a:p>
@@ -3982,7 +4637,7 @@
                 <a:ea typeface="Helvetica" pitchFamily="34" charset="-122"/>
                 <a:cs typeface="Helvetica" pitchFamily="34" charset="-120"/>
               </a:rPr>
-              <a:t>04 / 10</a:t>
+              <a:t>04 / 11</a:t>
             </a:r>
             <a:endParaRPr lang="en-US" sz="1000" dirty="0"/>
           </a:p>
@@ -4970,7 +5625,7 @@
                 <a:ea typeface="Helvetica" pitchFamily="34" charset="-122"/>
                 <a:cs typeface="Helvetica" pitchFamily="34" charset="-120"/>
               </a:rPr>
-              <a:t>05 / 10</a:t>
+              <a:t>05 / 11</a:t>
             </a:r>
             <a:endParaRPr lang="en-US" sz="1000" dirty="0"/>
           </a:p>
@@ -5508,7 +6163,7 @@
                 <a:ea typeface="Helvetica" pitchFamily="34" charset="-122"/>
                 <a:cs typeface="Helvetica" pitchFamily="34" charset="-120"/>
               </a:rPr>
-              <a:t>06 / 10</a:t>
+              <a:t>06 / 11</a:t>
             </a:r>
             <a:endParaRPr lang="en-US" sz="1000" dirty="0"/>
           </a:p>
@@ -6451,7 +7106,7 @@
                 <a:ea typeface="Helvetica" pitchFamily="34" charset="-122"/>
                 <a:cs typeface="Helvetica" pitchFamily="34" charset="-120"/>
               </a:rPr>
-              <a:t>07 / 10</a:t>
+              <a:t>07 / 11</a:t>
             </a:r>
             <a:endParaRPr lang="en-US" sz="1000" dirty="0"/>
           </a:p>
@@ -6848,7 +7503,7 @@
                 <a:ea typeface="Helvetica" pitchFamily="34" charset="-122"/>
                 <a:cs typeface="Helvetica" pitchFamily="34" charset="-120"/>
               </a:rPr>
-              <a:t>08 / 10</a:t>
+              <a:t>08 / 11</a:t>
             </a:r>
             <a:endParaRPr lang="en-US" sz="1000" dirty="0"/>
           </a:p>
@@ -7562,7 +8217,7 @@
                 <a:ea typeface="Helvetica" pitchFamily="34" charset="-122"/>
                 <a:cs typeface="Helvetica" pitchFamily="34" charset="-120"/>
               </a:rPr>
-              <a:t>09 / 10</a:t>
+              <a:t>09 / 11</a:t>
             </a:r>
             <a:endParaRPr lang="en-US" sz="1000" dirty="0"/>
           </a:p>

</xml_diff>